<commit_message>
chore: updated new vis
</commit_message>
<xml_diff>
--- a/SlateBlue_Information_Visualization_Poster.pptx
+++ b/SlateBlue_Information_Visualization_Poster.pptx
@@ -107,6 +107,11 @@
       </a:defRPr>
     </a:lvl9pPr>
   </p:defaultTextStyle>
+  <p:extLst>
+    <p:ext uri="{EFAFB233-063F-42B5-8137-9DF3F51BA10A}">
+      <p15:sldGuideLst xmlns:p15="http://schemas.microsoft.com/office/powerpoint/2012/main"/>
+    </p:ext>
+  </p:extLst>
 </p:presentation>
 </file>
 
@@ -722,7 +727,7 @@
 </file>
 
 <file path=ppt/slides/slide1.xml><?xml version="1.0" encoding="utf-8"?>
-<p:sld xmlns:a="http://schemas.openxmlformats.org/drawingml/2006/main" xmlns:ma14="http://schemas.microsoft.com/office/drawing/2014/main" xmlns:p="http://schemas.openxmlformats.org/presentationml/2006/main" xmlns:p14="http://schemas.microsoft.com/office/powerpoint/2010/main" xmlns:r="http://schemas.openxmlformats.org/officeDocument/2006/relationships">
+<p:sld xmlns:a="http://schemas.openxmlformats.org/drawingml/2006/main" xmlns:r="http://schemas.openxmlformats.org/officeDocument/2006/relationships" xmlns:p="http://schemas.openxmlformats.org/presentationml/2006/main">
   <p:cSld>
     <p:bg>
       <p:bgPr>
@@ -751,7 +756,7 @@
           <p:cNvPr id="43" name="poster-eyebrow">
             <a:extLst>
               <a:ext uri="{FF2B5EF4-FFF2-40B4-BE49-F238E27FC236}">
-                <ma14:creationId id="{E08A73F4-AF3B-4FB9-9199-6E75EBE57C78}"/>
+                <a16:creationId xmlns:a16="http://schemas.microsoft.com/office/drawing/2014/main" id="{E08A73F4-AF3B-4FB9-9199-6E75EBE57C78}"/>
               </a:ext>
             </a:extLst>
           </p:cNvPr>
@@ -801,7 +806,7 @@
           <p:cNvPr id="2" name="poster-title">
             <a:extLst>
               <a:ext uri="{FF2B5EF4-FFF2-40B4-BE49-F238E27FC236}">
-                <ma14:creationId id="{E8B61170-807C-41C5-A9C3-D1CB68BCC6F7}"/>
+                <a16:creationId xmlns:a16="http://schemas.microsoft.com/office/drawing/2014/main" id="{E8B61170-807C-41C5-A9C3-D1CB68BCC6F7}"/>
               </a:ext>
             </a:extLst>
           </p:cNvPr>
@@ -851,7 +856,7 @@
           <p:cNvPr id="3" name="poster-subtitle">
             <a:extLst>
               <a:ext uri="{FF2B5EF4-FFF2-40B4-BE49-F238E27FC236}">
-                <ma14:creationId id="{2A870308-500A-4C5D-8D3A-3876E006D13F}"/>
+                <a16:creationId xmlns:a16="http://schemas.microsoft.com/office/drawing/2014/main" id="{2A870308-500A-4C5D-8D3A-3876E006D13F}"/>
               </a:ext>
             </a:extLst>
           </p:cNvPr>
@@ -901,7 +906,7 @@
           <p:cNvPr id="4" name="course-label">
             <a:extLst>
               <a:ext uri="{FF2B5EF4-FFF2-40B4-BE49-F238E27FC236}">
-                <ma14:creationId id="{090F4A22-E112-478E-A19E-78AB5EA8286A}"/>
+                <a16:creationId xmlns:a16="http://schemas.microsoft.com/office/drawing/2014/main" id="{090F4A22-E112-478E-A19E-78AB5EA8286A}"/>
               </a:ext>
             </a:extLst>
           </p:cNvPr>
@@ -970,7 +975,7 @@
           <p:cNvPr id="5" name="header-rule">
             <a:extLst>
               <a:ext uri="{FF2B5EF4-FFF2-40B4-BE49-F238E27FC236}">
-                <ma14:creationId id="{4721218B-854A-49AE-BF77-AC9B17BD412F}"/>
+                <a16:creationId xmlns:a16="http://schemas.microsoft.com/office/drawing/2014/main" id="{4721218B-854A-49AE-BF77-AC9B17BD412F}"/>
               </a:ext>
             </a:extLst>
           </p:cNvPr>
@@ -1008,7 +1013,7 @@
           <p:cNvPr id="6" name="original-heading">
             <a:extLst>
               <a:ext uri="{FF2B5EF4-FFF2-40B4-BE49-F238E27FC236}">
-                <ma14:creationId id="{D7845612-A309-4213-A447-45EE0BDEA4E4}"/>
+                <a16:creationId xmlns:a16="http://schemas.microsoft.com/office/drawing/2014/main" id="{D7845612-A309-4213-A447-45EE0BDEA4E4}"/>
               </a:ext>
             </a:extLst>
           </p:cNvPr>
@@ -1058,7 +1063,7 @@
           <p:cNvPr id="7" name="original-image-frame">
             <a:extLst>
               <a:ext uri="{FF2B5EF4-FFF2-40B4-BE49-F238E27FC236}">
-                <ma14:creationId id="{9868A52F-0F2B-4F93-B202-28AFDC7E515D}"/>
+                <a16:creationId xmlns:a16="http://schemas.microsoft.com/office/drawing/2014/main" id="{9868A52F-0F2B-4F93-B202-28AFDC7E515D}"/>
               </a:ext>
             </a:extLst>
           </p:cNvPr>
@@ -1122,7 +1127,7 @@
           <p:cNvPr id="9" name="original-credit">
             <a:extLst>
               <a:ext uri="{FF2B5EF4-FFF2-40B4-BE49-F238E27FC236}">
-                <ma14:creationId id="{6C8419D4-7B52-40D4-A637-322E2D4DACB8}"/>
+                <a16:creationId xmlns:a16="http://schemas.microsoft.com/office/drawing/2014/main" id="{6C8419D4-7B52-40D4-A637-322E2D4DACB8}"/>
               </a:ext>
             </a:extLst>
           </p:cNvPr>
@@ -1189,7 +1194,7 @@
           <p:cNvPr id="10" name="left-divider">
             <a:extLst>
               <a:ext uri="{FF2B5EF4-FFF2-40B4-BE49-F238E27FC236}">
-                <ma14:creationId id="{84BA1672-618F-4A5D-AA17-2AD159FA8C07}"/>
+                <a16:creationId xmlns:a16="http://schemas.microsoft.com/office/drawing/2014/main" id="{84BA1672-618F-4A5D-AA17-2AD159FA8C07}"/>
               </a:ext>
             </a:extLst>
           </p:cNvPr>
@@ -1227,7 +1232,7 @@
           <p:cNvPr id="11" name="critique-heading">
             <a:extLst>
               <a:ext uri="{FF2B5EF4-FFF2-40B4-BE49-F238E27FC236}">
-                <ma14:creationId id="{2C358AD1-F061-41A0-A616-AD9065AED82B}"/>
+                <a16:creationId xmlns:a16="http://schemas.microsoft.com/office/drawing/2014/main" id="{2C358AD1-F061-41A0-A616-AD9065AED82B}"/>
               </a:ext>
             </a:extLst>
           </p:cNvPr>
@@ -1277,7 +1282,7 @@
           <p:cNvPr id="12" name="critique-item-1">
             <a:extLst>
               <a:ext uri="{FF2B5EF4-FFF2-40B4-BE49-F238E27FC236}">
-                <ma14:creationId id="{54BEEE7E-810E-4B36-B263-15F8038FB857}"/>
+                <a16:creationId xmlns:a16="http://schemas.microsoft.com/office/drawing/2014/main" id="{54BEEE7E-810E-4B36-B263-15F8038FB857}"/>
               </a:ext>
             </a:extLst>
           </p:cNvPr>
@@ -1327,7 +1332,7 @@
           <p:cNvPr id="13" name="critique-item-2">
             <a:extLst>
               <a:ext uri="{FF2B5EF4-FFF2-40B4-BE49-F238E27FC236}">
-                <ma14:creationId id="{28654507-EED0-43F0-9D5A-6768F6B9DFFC}"/>
+                <a16:creationId xmlns:a16="http://schemas.microsoft.com/office/drawing/2014/main" id="{28654507-EED0-43F0-9D5A-6768F6B9DFFC}"/>
               </a:ext>
             </a:extLst>
           </p:cNvPr>
@@ -1377,7 +1382,7 @@
           <p:cNvPr id="14" name="critique-item-3">
             <a:extLst>
               <a:ext uri="{FF2B5EF4-FFF2-40B4-BE49-F238E27FC236}">
-                <ma14:creationId id="{A8E35460-0C76-49E7-8113-054A4DD2459D}"/>
+                <a16:creationId xmlns:a16="http://schemas.microsoft.com/office/drawing/2014/main" id="{A8E35460-0C76-49E7-8113-054A4DD2459D}"/>
               </a:ext>
             </a:extLst>
           </p:cNvPr>
@@ -1427,7 +1432,7 @@
           <p:cNvPr id="15" name="critique-item-4">
             <a:extLst>
               <a:ext uri="{FF2B5EF4-FFF2-40B4-BE49-F238E27FC236}">
-                <ma14:creationId id="{FF747383-EB2D-4FE0-B3C8-9F0265A7AC62}"/>
+                <a16:creationId xmlns:a16="http://schemas.microsoft.com/office/drawing/2014/main" id="{FF747383-EB2D-4FE0-B3C8-9F0265A7AC62}"/>
               </a:ext>
             </a:extLst>
           </p:cNvPr>
@@ -1477,7 +1482,7 @@
           <p:cNvPr id="16" name="improved-heading">
             <a:extLst>
               <a:ext uri="{FF2B5EF4-FFF2-40B4-BE49-F238E27FC236}">
-                <ma14:creationId id="{028ADC3E-E420-4598-8203-105158713BE6}"/>
+                <a16:creationId xmlns:a16="http://schemas.microsoft.com/office/drawing/2014/main" id="{028ADC3E-E420-4598-8203-105158713BE6}"/>
               </a:ext>
             </a:extLst>
           </p:cNvPr>
@@ -1527,7 +1532,7 @@
           <p:cNvPr id="17" name="improved-image-frame">
             <a:extLst>
               <a:ext uri="{FF2B5EF4-FFF2-40B4-BE49-F238E27FC236}">
-                <ma14:creationId id="{90F028F8-7D50-4E87-ACB1-2203FBCFAE86}"/>
+                <a16:creationId xmlns:a16="http://schemas.microsoft.com/office/drawing/2014/main" id="{90F028F8-7D50-4E87-ACB1-2203FBCFAE86}"/>
               </a:ext>
             </a:extLst>
           </p:cNvPr>
@@ -1564,37 +1569,12 @@
           </a:p>
         </p:txBody>
       </p:sp>
-      <p:pic>
-        <p:nvPicPr>
-          <p:cNvPr id="60" name="Picture 59"/>
-          <p:cNvPicPr>
-            <a:picLocks noChangeAspect="1"/>
-          </p:cNvPicPr>
-          <p:nvPr/>
-        </p:nvPicPr>
-        <p:blipFill>
-          <a:blip r:embed="rId4"/>
-          <a:srcRect l="9888" t="9818" r="7845" b="6358"/>
-          <a:stretch>
-            <a:fillRect/>
-          </a:stretch>
-        </p:blipFill>
-        <p:spPr>
-          <a:xfrm>
-            <a:off x="5087360" y="1886733"/>
-            <a:ext cx="6494029" cy="4676014"/>
-          </a:xfrm>
-          <a:prstGeom prst="rect">
-            <a:avLst/>
-          </a:prstGeom>
-        </p:spPr>
-      </p:pic>
       <p:sp>
         <p:nvSpPr>
           <p:cNvPr id="19" name="right-context-surface">
             <a:extLst>
               <a:ext uri="{FF2B5EF4-FFF2-40B4-BE49-F238E27FC236}">
-                <ma14:creationId id="{84E17126-4A42-4FF3-9F8E-2722F6467CF0}"/>
+                <a16:creationId xmlns:a16="http://schemas.microsoft.com/office/drawing/2014/main" id="{84E17126-4A42-4FF3-9F8E-2722F6467CF0}"/>
               </a:ext>
             </a:extLst>
           </p:cNvPr>
@@ -1636,7 +1616,7 @@
           <p:cNvPr id="20" name="redesign-heading">
             <a:extLst>
               <a:ext uri="{FF2B5EF4-FFF2-40B4-BE49-F238E27FC236}">
-                <ma14:creationId id="{74F50EA3-E7A0-43C9-9346-B545829B9925}"/>
+                <a16:creationId xmlns:a16="http://schemas.microsoft.com/office/drawing/2014/main" id="{74F50EA3-E7A0-43C9-9346-B545829B9925}"/>
               </a:ext>
             </a:extLst>
           </p:cNvPr>
@@ -1686,7 +1666,7 @@
           <p:cNvPr id="21" name="redesign-item-1">
             <a:extLst>
               <a:ext uri="{FF2B5EF4-FFF2-40B4-BE49-F238E27FC236}">
-                <ma14:creationId id="{3E3B26D5-EEF7-4CFB-A635-FD58A2003410}"/>
+                <a16:creationId xmlns:a16="http://schemas.microsoft.com/office/drawing/2014/main" id="{3E3B26D5-EEF7-4CFB-A635-FD58A2003410}"/>
               </a:ext>
             </a:extLst>
           </p:cNvPr>
@@ -1736,7 +1716,7 @@
           <p:cNvPr id="22" name="redesign-item-2">
             <a:extLst>
               <a:ext uri="{FF2B5EF4-FFF2-40B4-BE49-F238E27FC236}">
-                <ma14:creationId id="{0346C853-5271-4D29-BE11-CDB38807DAFC}"/>
+                <a16:creationId xmlns:a16="http://schemas.microsoft.com/office/drawing/2014/main" id="{0346C853-5271-4D29-BE11-CDB38807DAFC}"/>
               </a:ext>
             </a:extLst>
           </p:cNvPr>
@@ -1786,7 +1766,7 @@
           <p:cNvPr id="23" name="redesign-item-3">
             <a:extLst>
               <a:ext uri="{FF2B5EF4-FFF2-40B4-BE49-F238E27FC236}">
-                <ma14:creationId id="{AE473FA0-362D-4D9D-9BC1-FA5BE6106E52}"/>
+                <a16:creationId xmlns:a16="http://schemas.microsoft.com/office/drawing/2014/main" id="{AE473FA0-362D-4D9D-9BC1-FA5BE6106E52}"/>
               </a:ext>
             </a:extLst>
           </p:cNvPr>
@@ -1836,7 +1816,7 @@
           <p:cNvPr id="24" name="redesign-item-4">
             <a:extLst>
               <a:ext uri="{FF2B5EF4-FFF2-40B4-BE49-F238E27FC236}">
-                <ma14:creationId id="{28D55F55-6A55-4537-BB84-1B39534AB0FA}"/>
+                <a16:creationId xmlns:a16="http://schemas.microsoft.com/office/drawing/2014/main" id="{28D55F55-6A55-4537-BB84-1B39534AB0FA}"/>
               </a:ext>
             </a:extLst>
           </p:cNvPr>
@@ -1886,7 +1866,7 @@
           <p:cNvPr id="25" name="context-divider">
             <a:extLst>
               <a:ext uri="{FF2B5EF4-FFF2-40B4-BE49-F238E27FC236}">
-                <ma14:creationId id="{C9AF6790-74A4-42AD-ABAE-E4528EED11B1}"/>
+                <a16:creationId xmlns:a16="http://schemas.microsoft.com/office/drawing/2014/main" id="{C9AF6790-74A4-42AD-ABAE-E4528EED11B1}"/>
               </a:ext>
             </a:extLst>
           </p:cNvPr>
@@ -1924,7 +1904,7 @@
           <p:cNvPr id="26" name="data-heading">
             <a:extLst>
               <a:ext uri="{FF2B5EF4-FFF2-40B4-BE49-F238E27FC236}">
-                <ma14:creationId id="{F0D2B5C4-4F9C-4629-A542-02693F6A7570}"/>
+                <a16:creationId xmlns:a16="http://schemas.microsoft.com/office/drawing/2014/main" id="{F0D2B5C4-4F9C-4629-A542-02693F6A7570}"/>
               </a:ext>
             </a:extLst>
           </p:cNvPr>
@@ -1974,7 +1954,7 @@
           <p:cNvPr id="27" name="data-emissions">
             <a:extLst>
               <a:ext uri="{FF2B5EF4-FFF2-40B4-BE49-F238E27FC236}">
-                <ma14:creationId id="{8CBBB212-A1ED-468E-B4D7-1E5EDC173F83}"/>
+                <a16:creationId xmlns:a16="http://schemas.microsoft.com/office/drawing/2014/main" id="{8CBBB212-A1ED-468E-B4D7-1E5EDC173F83}"/>
               </a:ext>
             </a:extLst>
           </p:cNvPr>
@@ -2058,7 +2038,7 @@
           <p:cNvPr id="28" name="data-population">
             <a:extLst>
               <a:ext uri="{FF2B5EF4-FFF2-40B4-BE49-F238E27FC236}">
-                <ma14:creationId id="{D469E2B5-59FB-4162-A57E-AC768AA840C6}"/>
+                <a16:creationId xmlns:a16="http://schemas.microsoft.com/office/drawing/2014/main" id="{D469E2B5-59FB-4162-A57E-AC768AA840C6}"/>
               </a:ext>
             </a:extLst>
           </p:cNvPr>
@@ -2125,7 +2105,7 @@
           <p:cNvPr id="29" name="data-gdp">
             <a:extLst>
               <a:ext uri="{FF2B5EF4-FFF2-40B4-BE49-F238E27FC236}">
-                <ma14:creationId id="{84EAF8B0-BC7C-4E68-B2C3-CF36913C6F12}"/>
+                <a16:creationId xmlns:a16="http://schemas.microsoft.com/office/drawing/2014/main" id="{84EAF8B0-BC7C-4E68-B2C3-CF36913C6F12}"/>
               </a:ext>
             </a:extLst>
           </p:cNvPr>
@@ -2192,7 +2172,7 @@
           <p:cNvPr id="30" name="gdp-interpretation">
             <a:extLst>
               <a:ext uri="{FF2B5EF4-FFF2-40B4-BE49-F238E27FC236}">
-                <ma14:creationId id="{E932DB87-F094-4694-8C3C-EF781D36A277}"/>
+                <a16:creationId xmlns:a16="http://schemas.microsoft.com/office/drawing/2014/main" id="{E932DB87-F094-4694-8C3C-EF781D36A277}"/>
               </a:ext>
             </a:extLst>
           </p:cNvPr>
@@ -2242,7 +2222,7 @@
           <p:cNvPr id="31" name="design-brief-surface">
             <a:extLst>
               <a:ext uri="{FF2B5EF4-FFF2-40B4-BE49-F238E27FC236}">
-                <ma14:creationId id="{A907F6A4-85B6-4A7F-A19B-75FCE59248A6}"/>
+                <a16:creationId xmlns:a16="http://schemas.microsoft.com/office/drawing/2014/main" id="{A907F6A4-85B6-4A7F-A19B-75FCE59248A6}"/>
               </a:ext>
             </a:extLst>
           </p:cNvPr>
@@ -2284,7 +2264,7 @@
           <p:cNvPr id="32" name="design-brief-heading">
             <a:extLst>
               <a:ext uri="{FF2B5EF4-FFF2-40B4-BE49-F238E27FC236}">
-                <ma14:creationId id="{9F70041F-ADF4-40E8-A3DD-C8866294561F}"/>
+                <a16:creationId xmlns:a16="http://schemas.microsoft.com/office/drawing/2014/main" id="{9F70041F-ADF4-40E8-A3DD-C8866294561F}"/>
               </a:ext>
             </a:extLst>
           </p:cNvPr>
@@ -2334,7 +2314,7 @@
           <p:cNvPr id="33" name="design-brief-audience">
             <a:extLst>
               <a:ext uri="{FF2B5EF4-FFF2-40B4-BE49-F238E27FC236}">
-                <ma14:creationId id="{E794E44D-05BE-4606-980E-823BDBC3A37F}"/>
+                <a16:creationId xmlns:a16="http://schemas.microsoft.com/office/drawing/2014/main" id="{E794E44D-05BE-4606-980E-823BDBC3A37F}"/>
               </a:ext>
             </a:extLst>
           </p:cNvPr>
@@ -2384,7 +2364,7 @@
           <p:cNvPr id="34" name="brief-column-divider">
             <a:extLst>
               <a:ext uri="{FF2B5EF4-FFF2-40B4-BE49-F238E27FC236}">
-                <ma14:creationId id="{DA79E8F1-A9D2-4647-8A45-4910A0E588B5}"/>
+                <a16:creationId xmlns:a16="http://schemas.microsoft.com/office/drawing/2014/main" id="{DA79E8F1-A9D2-4647-8A45-4910A0E588B5}"/>
               </a:ext>
             </a:extLst>
           </p:cNvPr>
@@ -2422,7 +2402,7 @@
           <p:cNvPr id="35" name="main-revisions-heading">
             <a:extLst>
               <a:ext uri="{FF2B5EF4-FFF2-40B4-BE49-F238E27FC236}">
-                <ma14:creationId id="{BE55EB57-41FB-4943-AFE3-5585C6BA7B2F}"/>
+                <a16:creationId xmlns:a16="http://schemas.microsoft.com/office/drawing/2014/main" id="{BE55EB57-41FB-4943-AFE3-5585C6BA7B2F}"/>
               </a:ext>
             </a:extLst>
           </p:cNvPr>
@@ -2472,7 +2452,7 @@
           <p:cNvPr id="36" name="brief-item-1">
             <a:extLst>
               <a:ext uri="{FF2B5EF4-FFF2-40B4-BE49-F238E27FC236}">
-                <ma14:creationId id="{1A8B18F2-753B-4108-BAFD-3D0C19CB8764}"/>
+                <a16:creationId xmlns:a16="http://schemas.microsoft.com/office/drawing/2014/main" id="{1A8B18F2-753B-4108-BAFD-3D0C19CB8764}"/>
               </a:ext>
             </a:extLst>
           </p:cNvPr>
@@ -2522,7 +2502,7 @@
           <p:cNvPr id="37" name="brief-item-2">
             <a:extLst>
               <a:ext uri="{FF2B5EF4-FFF2-40B4-BE49-F238E27FC236}">
-                <ma14:creationId id="{89419B57-F613-419B-9936-5F5E475498C6}"/>
+                <a16:creationId xmlns:a16="http://schemas.microsoft.com/office/drawing/2014/main" id="{89419B57-F613-419B-9936-5F5E475498C6}"/>
               </a:ext>
             </a:extLst>
           </p:cNvPr>
@@ -2572,7 +2552,7 @@
           <p:cNvPr id="38" name="brief-item-3">
             <a:extLst>
               <a:ext uri="{FF2B5EF4-FFF2-40B4-BE49-F238E27FC236}">
-                <ma14:creationId id="{541613F4-D73D-49EA-905A-C937A564B748}"/>
+                <a16:creationId xmlns:a16="http://schemas.microsoft.com/office/drawing/2014/main" id="{541613F4-D73D-49EA-905A-C937A564B748}"/>
               </a:ext>
             </a:extLst>
           </p:cNvPr>
@@ -2622,7 +2602,7 @@
           <p:cNvPr id="39" name="brief-item-4">
             <a:extLst>
               <a:ext uri="{FF2B5EF4-FFF2-40B4-BE49-F238E27FC236}">
-                <ma14:creationId id="{F92F00F2-B48C-4C4A-9AF1-2D58398CB386}"/>
+                <a16:creationId xmlns:a16="http://schemas.microsoft.com/office/drawing/2014/main" id="{F92F00F2-B48C-4C4A-9AF1-2D58398CB386}"/>
               </a:ext>
             </a:extLst>
           </p:cNvPr>
@@ -2672,7 +2652,7 @@
           <p:cNvPr id="40" name="brief-item-5">
             <a:extLst>
               <a:ext uri="{FF2B5EF4-FFF2-40B4-BE49-F238E27FC236}">
-                <ma14:creationId id="{65207A74-7247-4067-92EC-FF1656AD8C19}"/>
+                <a16:creationId xmlns:a16="http://schemas.microsoft.com/office/drawing/2014/main" id="{65207A74-7247-4067-92EC-FF1656AD8C19}"/>
               </a:ext>
             </a:extLst>
           </p:cNvPr>
@@ -2722,7 +2702,7 @@
           <p:cNvPr id="41" name="footer-source">
             <a:extLst>
               <a:ext uri="{FF2B5EF4-FFF2-40B4-BE49-F238E27FC236}">
-                <ma14:creationId id="{27DEA7E4-E67E-44DF-918F-E24922A2808E}"/>
+                <a16:creationId xmlns:a16="http://schemas.microsoft.com/office/drawing/2014/main" id="{27DEA7E4-E67E-44DF-918F-E24922A2808E}"/>
               </a:ext>
             </a:extLst>
           </p:cNvPr>
@@ -2772,7 +2752,7 @@
           <p:cNvPr id="42" name="footer-team">
             <a:extLst>
               <a:ext uri="{FF2B5EF4-FFF2-40B4-BE49-F238E27FC236}">
-                <ma14:creationId id="{18262459-389B-4187-ACB9-6D50A32D75BF}"/>
+                <a16:creationId xmlns:a16="http://schemas.microsoft.com/office/drawing/2014/main" id="{18262459-389B-4187-ACB9-6D50A32D75BF}"/>
               </a:ext>
             </a:extLst>
           </p:cNvPr>
@@ -2817,10 +2797,46 @@
           </a:p>
         </p:txBody>
       </p:sp>
+      <p:pic>
+        <p:nvPicPr>
+          <p:cNvPr id="18" name="Picture 17">
+            <a:extLst>
+              <a:ext uri="{FF2B5EF4-FFF2-40B4-BE49-F238E27FC236}">
+                <a16:creationId xmlns:a16="http://schemas.microsoft.com/office/drawing/2014/main" id="{4DC8CC8D-7A04-E0F6-2D3F-BEBB250715A7}"/>
+              </a:ext>
+            </a:extLst>
+          </p:cNvPr>
+          <p:cNvPicPr>
+            <a:picLocks noChangeAspect="1"/>
+          </p:cNvPicPr>
+          <p:nvPr/>
+        </p:nvPicPr>
+        <p:blipFill>
+          <a:blip r:embed="rId4">
+            <a:extLst>
+              <a:ext uri="{28A0092B-C50C-407E-A947-70E740481C1C}">
+                <a14:useLocalDpi xmlns:a14="http://schemas.microsoft.com/office/drawing/2010/main" val="0"/>
+              </a:ext>
+            </a:extLst>
+          </a:blip>
+          <a:stretch>
+            <a:fillRect/>
+          </a:stretch>
+        </p:blipFill>
+        <p:spPr>
+          <a:xfrm>
+            <a:off x="5349405" y="1819275"/>
+            <a:ext cx="5969940" cy="4810125"/>
+          </a:xfrm>
+          <a:prstGeom prst="rect">
+            <a:avLst/>
+          </a:prstGeom>
+        </p:spPr>
+      </p:pic>
     </p:spTree>
     <p:extLst>
       <p:ext uri="{BB962C8B-B14F-4D97-AF65-F5344CB8AC3E}">
-        <p14:creationId val="1463500918"/>
+        <p14:creationId xmlns:p14="http://schemas.microsoft.com/office/powerpoint/2010/main" val="1463500918"/>
       </p:ext>
     </p:extLst>
   </p:cSld>

</xml_diff>